<commit_message>
Added Skill and Content and Lectures
</commit_message>
<xml_diff>
--- a/Storyboarding/NewLectures/05_Composition_REVISED.pptx
+++ b/Storyboarding/NewLectures/05_Composition_REVISED.pptx
@@ -1276,7 +1276,7 @@
           <a:lstStyle/>
           <a:p>
             <a:r>
-              <a:t>This is one animation figured out long before anyone wrote it down, and your animation majors will recognise it immediately. Round shapes read as safe and appealing. Squares read as dependable and immovable. Angles read as threat. Look at almost any animated cast and the villain has sharper shapes than the hero. It applies to environments and props too, not just characters. A room built from angles is not a safe room, and you did not have to tell anyone that.</a:t>
+              <a:t>This is one animation figured out long before anyone wrote it down, and your animation majors will recognize it immediately. Round shapes read as safe and appealing. Squares read as dependable and immovable. Angles read as threat. Look at almost any animated cast and the villain has sharper shapes than the hero. It applies to environments and props too, not just characters. A room built from angles is not a safe room, and you did not have to tell anyone that.</a:t>
             </a:r>
           </a:p>
         </p:txBody>
@@ -1632,7 +1632,7 @@
           <a:lstStyle/>
           <a:p>
             <a:r>
-              <a:t>Squint until everything blurs into masses of light and dark. That blurred version is roughly what the audience gets in half a second. If your character disappears into the background when you squint, no amount of line work will save it. Shrink your panel to thumbnail size: same test, and it is why we thumbnail in the first place. This takes two seconds and it will catch more problems than any other habit I can give you.</a:t>
+              <a:t>Squint until everything blurs into masses of light and dark. That blurred version is roughly what the audience gets in half a second. If your character disappears into the background when you squint, no amount of line work will save it. Shrink your panel to thumbnail size: same test, and it is why we thumbnail in the first place. This takes two seconds and it will catch more problems than any other habit on this list.</a:t>
             </a:r>
           </a:p>
         </p:txBody>
@@ -1702,7 +1702,7 @@
           <a:lstStyle/>
           <a:p>
             <a:r>
-              <a:t>Figure and ground. Your subject is the figure; everything behind it is the ground. They have to be different in value or the eye cannot separate them. The most common student failure is a mid-grey character standing in front of a mid-grey background. Every line is drawn correctly and the panel is still unreadable. The good news is that this has nothing whatsoever to do with drawing ability. It is a decision, and you can make it correctly on the very first panel you ever draw.</a:t>
+              <a:t>Figure and ground. Your subject is the figure; everything behind it is the ground. They have to be different in value or the eye cannot separate them. The most common student failure is a mid-gray character standing in front of a mid-gray background. Every line is drawn correctly and the panel is still unreadable. The good news is that this has nothing whatsoever to do with drawing ability. It is a decision, and you can make it correctly on the very first panel you ever draw.</a:t>
             </a:r>
           </a:p>
         </p:txBody>
@@ -1842,7 +1842,7 @@
           <a:lstStyle/>
           <a:p>
             <a:r>
-              <a:t>The silhouette test. Fill the figure in solid black and see whether the action still reads. Animation has used this for a century, and it is a hiring criterion in games for character design. It is also completely independent of your skill level, which is why I keep coming back to it. A badly drawn figure with a strong silhouette communicates. A beautifully drawn figure with a weak one does not. In this class, the first one gets the better grade.</a:t>
+              <a:t>The silhouette test. Fill the figure in solid black and see whether the action still reads. Animation has used this for a century, and it is a hiring criterion in games for character design. It is also completely independent of your skill level, which is why it keeps coming back. A badly drawn figure with a strong silhouette communicates. A beautifully drawn figure with a weak one does not. In this class, the first one gets the better grade.</a:t>
             </a:r>
           </a:p>
         </p:txBody>
@@ -1912,7 +1912,7 @@
           <a:lstStyle/>
           <a:p>
             <a:r>
-              <a:t>Things further away are lighter and lower in contrast because there is air in the way. Painters have used this for centuries and it is the cheapest depth cue you own. Here is why I am emphasising it: it does not require you to be good at perspective. If your vanishing points are a mess but your value depth is right, the panel still reads as deep. For a lot of you that is an important escape hatch, and it is not a compromise: professionals rely on it too.</a:t>
+              <a:t>Things further away are lighter and lower in contrast because there is air in the way. Painters have used this for centuries and it is the cheapest depth cue you own. Here is why it matters: it does not require you to be good at perspective. If your vanishing points are a mess but your value depth is right, the panel still reads as deep. For a lot of you that is an important escape hatch, and it is not a compromise: professionals rely on it too.</a:t>
             </a:r>
           </a:p>
         </p:txBody>
@@ -2052,7 +2052,7 @@
           <a:lstStyle/>
           <a:p>
             <a:r>
-              <a:t>Divide the frame into thirds horizontally and vertically and you get four intersection points. Subjects placed there tend to be more interesting than subjects dead centre. This is genuinely useful and also genuinely overrated: treat it as the answer when you do not have a better one, not as a rule you must obey. It is a floor, not a ceiling.</a:t>
+              <a:t>Divide the frame into thirds horizontally and vertically and you get four intersection points. Subjects placed there tend to be more interesting than subjects dead center. This is useful, and it's also overrated: treat it as the answer when you do not have a better one, not as a rule you must obey. It is a floor, not a ceiling.</a:t>
             </a:r>
           </a:p>
         </p:txBody>
@@ -2192,7 +2192,7 @@
           <a:lstStyle/>
           <a:p>
             <a:r>
-              <a:t>Sometimes dead centre is exactly right. Symmetry reads as formal and controlled, which is why it shows up for thrones, altars, and villains. Kubrick built a career on it. There is also a practical reason. Mad Max: Fury Road centred nearly every shot on purpose, because at that cutting speed the audience needs to find the subject instantly and the centre is where the eye already is. Worth knowing when you are boarding fast action.</a:t>
+              <a:t>Sometimes dead center is exactly right. Symmetry reads as formal and controlled, which is why it shows up for thrones, altars, and villains. Kubrick built a career on it. There is also a practical reason. Mad Max: Fury Road centered nearly every shot on purpose, because at that cutting speed the audience needs to find the subject instantly and the center is where the eye already is. Worth knowing when you are boarding fast action.</a:t>
             </a:r>
           </a:p>
         </p:txBody>
@@ -2402,7 +2402,7 @@
           <a:lstStyle/>
           <a:p>
             <a:r>
-              <a:t>Every frame needs a hierarchy: one dominant element, some sub-dominant, and the rest subordinate. This is the vocabulary I will use in critique, so learn it now. When I say a panel does not read, what I usually mean is that two things are competing to be dominant and the eye cannot choose. One dominant per frame. If two things matter equally, you probably need two shots.</a:t>
+              <a:t>Every frame needs a hierarchy: one dominant element, some sub-dominant, and the rest subordinate. This is the vocabulary critique uses, so learn it now. When a panel does not read, it usually means two things are competing to be dominant and the eye cannot choose. One dominant per frame. If two things matter equally, you probably need two shots.</a:t>
             </a:r>
           </a:p>
         </p:txBody>
@@ -2612,7 +2612,7 @@
           <a:lstStyle/>
           <a:p>
             <a:r>
-              <a:t>Framing the subject inside something else: a doorway, a window, a gap between foreground shapes. It does three things at once: it isolates the subject, it creates depth by giving you a foreground, and it can carry meaning. A character framed in a doorway is contained by it. And it is genuinely easy to draw. Two dark shapes at the edges of your panel will do it.</a:t>
+              <a:t>Framing the subject inside something else: a doorway, a window, a gap between foreground shapes. It does three things at once: it isolates the subject, it creates depth by giving you a foreground, and it can carry meaning. A character framed in a doorway is contained by it. And it is easy to draw. Two dark shapes at the edges of your panel will do it.</a:t>
             </a:r>
           </a:p>
         </p:txBody>
@@ -2892,7 +2892,7 @@
           <a:lstStyle/>
           <a:p>
             <a:r>
-              <a:t>When composition works, nobody compliments it. They just follow the story. When it fails, everyone notices, though almost nobody can say why. They say it looks off, or cheap, or confusing. That is your diagnostic. When someone tells you a shot feels wrong, translate it into: my eye went to the wrong place, or my eye did not know where to go at all. Then it is a fixable problem instead of a vague complaint.</a:t>
+              <a:t>When composition works, nobody compliments it. They just follow the story. When it fails, everyone notices, though almost nobody can say why. They say it looks off, or cheap, or confusing. That is your diagnostic. When someone tells you a shot feels wrong, translate it into: the eye went to the wrong place, or the eye did not know where to go at all. Then it is a fixable problem instead of a vague complaint.</a:t>
             </a:r>
           </a:p>
         </p:txBody>
@@ -3242,7 +3242,7 @@
           <a:lstStyle/>
           <a:p>
             <a:r>
-              <a:t>Here is the meaning that a graphic design course will never give you. In motion, rhythm is also temporal: the pattern of your cutting. Long, long, long, short. Short short short short. A held silence where the audience expects a cut. This is the musical sense of the word and it is doing the same job that beat and tempo do in music: creating expectation and then satisfying or denying it. You will feel this properly when you build your animatic. Right now, just know that when I say rhythm, I might mean either one.</a:t>
+              <a:t>Here is the meaning that a graphic design course will never give you. In motion, rhythm is also temporal: the pattern of your cutting. Long, long, long, short. Short short short short. A held silence where the audience expects a cut. This is the musical sense of the word and it is doing the same job that beat and tempo do in music: creating expectation and then satisfying or denying it. You will feel this properly when you build your animatic. Right now, just know that the word can mean either one.</a:t>
             </a:r>
           </a:p>
         </p:txBody>
@@ -3382,7 +3382,7 @@
           <a:lstStyle/>
           <a:p>
             <a:r>
-              <a:t>An animation instructor I heard years ago called this ballistics, and the word has stuck with me. Information has momentum. The audience does not reset at a cut. They carry what they just learned, and their eye is still physically pointed where the last shot left it. So the question is never just "does this frame work." It is "where is the audience arriving from, and where am I sending them next." That trajectory is the thing you are actually designing.</a:t>
+              <a:t>This term comes from an animation instructor, borrowed because it names something real. Information has momentum. The audience does not reset at a cut. They carry what they just learned, and their eye is still physically pointed where the last shot left it. So the question is never just "does this frame work." It is "where is the audience arriving from, and where am I sending them next." That trajectory is the thing you are actually designing.</a:t>
             </a:r>
           </a:p>
         </p:txBody>
@@ -4018,7 +4018,7 @@
           <a:lstStyle/>
           <a:p>
             <a:r>
-              <a:t>Before we can talk about arranging things, we need names for the things. This is deliberately basic. If you have a design background, give me ten minutes and we will be past it. If you do not, this is the vocabulary that the rest of the semester assumes you have.</a:t>
+              <a:t>Before we can talk about arranging things, we need names for the things. This is deliberately basic. If you have a design background, this section moves fast, and we will be past it in a few minutes. If you do not, this is the vocabulary that the rest of the semester assumes you have.</a:t>
             </a:r>
           </a:p>
         </p:txBody>
@@ -4088,7 +4088,7 @@
           <a:lstStyle/>
           <a:p>
             <a:r>
-              <a:t>Six elements. Line, shape, direction, size, texture, value. Notice colour is not on this list. Colour matters enormously in a finished film and it will come up in the lighting session, but the overwhelming majority of storyboards are made in greyscale, so it is not one of the tools you will use here. Of these six, one is doing more work than the other five combined.</a:t>
+              <a:t>Six elements. Line, shape, direction, size, texture, value. Notice color is not on this list. Color matters enormously in a finished film and it will come up in the lighting session, but the overwhelming majority of storyboards are made in grayscale, so it is not one of the tools you will use here. Of these six, one is doing more work than the other five combined.</a:t>
             </a:r>
           </a:p>
         </p:txBody>
@@ -4158,7 +4158,7 @@
           <a:lstStyle/>
           <a:p>
             <a:r>
-              <a:t>Value is the difference between light and dark, and it is the single most powerful compositional tool you own. Here is why it matters more to you than to a graphic designer. Your panel might be on screen for twelve frames. The eye resolves value before it resolves detail, before it resolves colour, before it can read a face. If your values are working, a very rough drawing communicates instantly. If they are not, all the rendering in the world will not save the shot. We will come back to this with a whole section.</a:t>
+              <a:t>Value is the difference between light and dark, and it is the single most powerful compositional tool you own. Here is why it matters more to you than to a graphic designer. Your panel might be on screen for twelve frames. The eye resolves value before it resolves detail, before it resolves color, before it can read a face. If your values are working, a very rough drawing communicates instantly. If they are not, all the rendering in the world will not save the shot. We will come back to this with a whole section.</a:t>
             </a:r>
           </a:p>
         </p:txBody>
@@ -18237,7 +18237,7 @@
           <a:p>
             <a:r>
               <a:rPr lang="en-US" dirty="0" b="0"/>
-              <a:t>Black, mid-grey, white</a:t>
+              <a:t>Black, mid-gray, white</a:t>
             </a:r>
           </a:p>
           <a:p>
@@ -18360,7 +18360,7 @@
           <a:p>
             <a:r>
               <a:rPr lang="en-US" dirty="0" b="0"/>
-              <a:t>This is the standard I grade against</a:t>
+              <a:t>This is the standard this course grades against</a:t>
             </a:r>
           </a:p>
         </p:txBody>
@@ -18975,7 +18975,7 @@
                 </a:solidFill>
                 <a:latin typeface="Garamond"/>
               </a:rPr>
-              <a:t>Subject on an intersection, not dead centre</a:t>
+              <a:t>Subject on an intersection, not dead center</a:t>
             </a:r>
           </a:p>
         </p:txBody>
@@ -19132,7 +19132,7 @@
           <a:p>
             <a:r>
               <a:rPr lang="en-US" sz="4400" dirty="0" b="0"/>
-              <a:t>When to Centre</a:t>
+              <a:t>When to Center</a:t>
             </a:r>
           </a:p>
         </p:txBody>
@@ -19341,7 +19341,7 @@
                 </a:solidFill>
                 <a:latin typeface="Garamond"/>
               </a:rPr>
-              <a:t>Centred: formal, controlled</a:t>
+              <a:t>Centered: formal, controlled</a:t>
             </a:r>
           </a:p>
         </p:txBody>
@@ -19512,7 +19512,7 @@
                 </a:solidFill>
                 <a:latin typeface="Garamond"/>
               </a:rPr>
-              <a:t>Off-centre: observed, natural</a:t>
+              <a:t>Off-center: observed, natural</a:t>
             </a:r>
           </a:p>
         </p:txBody>
@@ -22071,7 +22071,7 @@
           <a:p>
             <a:r>
               <a:rPr lang="en-US" dirty="0" b="0"/>
-              <a:t>You are composing for a brain that is trying to organise</a:t>
+              <a:t>You are composing for a brain that is trying to organize</a:t>
             </a:r>
           </a:p>
         </p:txBody>
@@ -22170,7 +22170,7 @@
           <a:p>
             <a:r>
               <a:rPr lang="en-US" dirty="0" b="0"/>
-              <a:t>"It looks weird" usually means "I looked at the wrong thing"</a:t>
+              <a:t>"It looks weird" usually means "the eye went to the wrong place"</a:t>
             </a:r>
           </a:p>
         </p:txBody>

</xml_diff>